<commit_message>
feat: 5 integraciones - GPS en vivo, editar nombre, QR boletos, ubicacion silenciosa
</commit_message>
<xml_diff>
--- a/pruebas/Presentacion_Pruebas_PremiumBus.pptx
+++ b/pruebas/Presentacion_Pruebas_PremiumBus.pptx
@@ -126,7 +126,7 @@
 <file path=ppt/revisionInfo.xml><?xml version="1.0" encoding="utf-8"?>
 <p1510:revInfo xmlns:a="http://schemas.openxmlformats.org/drawingml/2006/main" xmlns:r="http://schemas.openxmlformats.org/officeDocument/2006/relationships" xmlns:p1510="http://schemas.microsoft.com/office/powerpoint/2015/10/main">
   <p1510:revLst>
-    <p1510:client id="{5873AF80-AC87-43DD-9A37-2B073514D751}" v="3" dt="2026-05-06T00:34:08.154"/>
+    <p1510:client id="{5873AF80-AC87-43DD-9A37-2B073514D751}" v="9" dt="2026-05-06T01:34:22.376"/>
   </p1510:revLst>
 </p1510:revInfo>
 </file>
@@ -136,12 +136,51 @@
   <pc:docChgLst>
     <pc:chgData name="David Coronado" userId="58e676e7eb816da9" providerId="LiveId" clId="{7F77D59E-842D-437D-AA28-71301E20DF3F}"/>
     <pc:docChg chg="undo custSel modSld">
-      <pc:chgData name="David Coronado" userId="58e676e7eb816da9" providerId="LiveId" clId="{7F77D59E-842D-437D-AA28-71301E20DF3F}" dt="2026-05-06T00:35:53.716" v="106" actId="1076"/>
+      <pc:chgData name="David Coronado" userId="58e676e7eb816da9" providerId="LiveId" clId="{7F77D59E-842D-437D-AA28-71301E20DF3F}" dt="2026-05-06T01:34:35.532" v="158" actId="14100"/>
       <pc:docMkLst>
         <pc:docMk/>
       </pc:docMkLst>
       <pc:sldChg chg="addSp modSp mod">
-        <pc:chgData name="David Coronado" userId="58e676e7eb816da9" providerId="LiveId" clId="{7F77D59E-842D-437D-AA28-71301E20DF3F}" dt="2026-05-06T00:14:38.654" v="16" actId="14100"/>
+        <pc:chgData name="David Coronado" userId="58e676e7eb816da9" providerId="LiveId" clId="{7F77D59E-842D-437D-AA28-71301E20DF3F}" dt="2026-05-06T01:28:58.543" v="150" actId="20577"/>
+        <pc:sldMkLst>
+          <pc:docMk/>
+          <pc:sldMk cId="0" sldId="256"/>
+        </pc:sldMkLst>
+        <pc:spChg chg="mod">
+          <ac:chgData name="David Coronado" userId="58e676e7eb816da9" providerId="LiveId" clId="{7F77D59E-842D-437D-AA28-71301E20DF3F}" dt="2026-05-06T01:22:09.989" v="134" actId="20577"/>
+          <ac:spMkLst>
+            <pc:docMk/>
+            <pc:sldMk cId="0" sldId="256"/>
+            <ac:spMk id="4" creationId="{00000000-0000-0000-0000-000000000000}"/>
+          </ac:spMkLst>
+        </pc:spChg>
+        <pc:spChg chg="mod">
+          <ac:chgData name="David Coronado" userId="58e676e7eb816da9" providerId="LiveId" clId="{7F77D59E-842D-437D-AA28-71301E20DF3F}" dt="2026-05-06T01:22:25.995" v="137" actId="1076"/>
+          <ac:spMkLst>
+            <pc:docMk/>
+            <pc:sldMk cId="0" sldId="256"/>
+            <ac:spMk id="5" creationId="{00000000-0000-0000-0000-000000000000}"/>
+          </ac:spMkLst>
+        </pc:spChg>
+        <pc:spChg chg="mod">
+          <ac:chgData name="David Coronado" userId="58e676e7eb816da9" providerId="LiveId" clId="{7F77D59E-842D-437D-AA28-71301E20DF3F}" dt="2026-05-06T01:28:58.543" v="150" actId="20577"/>
+          <ac:spMkLst>
+            <pc:docMk/>
+            <pc:sldMk cId="0" sldId="256"/>
+            <ac:spMk id="6" creationId="{00000000-0000-0000-0000-000000000000}"/>
+          </ac:spMkLst>
+        </pc:spChg>
+        <pc:spChg chg="add mod">
+          <ac:chgData name="David Coronado" userId="58e676e7eb816da9" providerId="LiveId" clId="{7F77D59E-842D-437D-AA28-71301E20DF3F}" dt="2026-05-06T01:28:27.619" v="140" actId="1076"/>
+          <ac:spMkLst>
+            <pc:docMk/>
+            <pc:sldMk cId="0" sldId="256"/>
+            <ac:spMk id="7" creationId="{0483594A-628C-64DB-0561-262D485D1966}"/>
+          </ac:spMkLst>
+        </pc:spChg>
+      </pc:sldChg>
+      <pc:sldChg chg="addSp delSp modSp mod">
+        <pc:chgData name="David Coronado" userId="58e676e7eb816da9" providerId="LiveId" clId="{7F77D59E-842D-437D-AA28-71301E20DF3F}" dt="2026-05-06T01:34:35.532" v="158" actId="14100"/>
         <pc:sldMkLst>
           <pc:docMk/>
           <pc:sldMk cId="0" sldId="257"/>
@@ -162,20 +201,36 @@
             <ac:spMk id="13" creationId="{00000000-0000-0000-0000-000000000000}"/>
           </ac:spMkLst>
         </pc:spChg>
+        <pc:spChg chg="add">
+          <ac:chgData name="David Coronado" userId="58e676e7eb816da9" providerId="LiveId" clId="{7F77D59E-842D-437D-AA28-71301E20DF3F}" dt="2026-05-06T01:34:20.766" v="152"/>
+          <ac:spMkLst>
+            <pc:docMk/>
+            <pc:sldMk cId="0" sldId="257"/>
+            <ac:spMk id="18" creationId="{75DB4835-D78B-B015-976C-3086C8863FC2}"/>
+          </ac:spMkLst>
+        </pc:spChg>
         <pc:picChg chg="add mod">
-          <ac:chgData name="David Coronado" userId="58e676e7eb816da9" providerId="LiveId" clId="{7F77D59E-842D-437D-AA28-71301E20DF3F}" dt="2026-05-06T00:14:32.022" v="13" actId="1076"/>
+          <ac:chgData name="David Coronado" userId="58e676e7eb816da9" providerId="LiveId" clId="{7F77D59E-842D-437D-AA28-71301E20DF3F}" dt="2026-05-06T01:34:35.532" v="158" actId="14100"/>
           <ac:picMkLst>
             <pc:docMk/>
             <pc:sldMk cId="0" sldId="257"/>
             <ac:picMk id="15" creationId="{6A6D2BB3-02C4-1F5A-5FA9-C8CFB6A98C81}"/>
           </ac:picMkLst>
         </pc:picChg>
-        <pc:picChg chg="add mod">
-          <ac:chgData name="David Coronado" userId="58e676e7eb816da9" providerId="LiveId" clId="{7F77D59E-842D-437D-AA28-71301E20DF3F}" dt="2026-05-06T00:14:38.654" v="16" actId="14100"/>
+        <pc:picChg chg="add del mod">
+          <ac:chgData name="David Coronado" userId="58e676e7eb816da9" providerId="LiveId" clId="{7F77D59E-842D-437D-AA28-71301E20DF3F}" dt="2026-05-06T01:34:08.992" v="151" actId="478"/>
           <ac:picMkLst>
             <pc:docMk/>
             <pc:sldMk cId="0" sldId="257"/>
             <ac:picMk id="17" creationId="{08D2BB91-B152-1B59-091D-6F19B99A950C}"/>
+          </ac:picMkLst>
+        </pc:picChg>
+        <pc:picChg chg="add mod">
+          <ac:chgData name="David Coronado" userId="58e676e7eb816da9" providerId="LiveId" clId="{7F77D59E-842D-437D-AA28-71301E20DF3F}" dt="2026-05-06T01:34:32.938" v="157" actId="1076"/>
+          <ac:picMkLst>
+            <pc:docMk/>
+            <pc:sldMk cId="0" sldId="257"/>
+            <ac:picMk id="20" creationId="{ECA053AF-0BFB-466A-2456-B51AC1041EFD}"/>
           </ac:picMkLst>
         </pc:picChg>
       </pc:sldChg>
@@ -397,8 +452,8 @@
           </ac:picMkLst>
         </pc:picChg>
       </pc:sldChg>
-      <pc:sldChg chg="modSp mod">
-        <pc:chgData name="David Coronado" userId="58e676e7eb816da9" providerId="LiveId" clId="{7F77D59E-842D-437D-AA28-71301E20DF3F}" dt="2026-05-06T00:22:19.912" v="86" actId="14100"/>
+      <pc:sldChg chg="addSp modSp mod">
+        <pc:chgData name="David Coronado" userId="58e676e7eb816da9" providerId="LiveId" clId="{7F77D59E-842D-437D-AA28-71301E20DF3F}" dt="2026-05-06T01:18:06.616" v="111" actId="1076"/>
         <pc:sldMkLst>
           <pc:docMk/>
           <pc:sldMk cId="0" sldId="264"/>
@@ -419,9 +474,25 @@
             <ac:spMk id="13" creationId="{00000000-0000-0000-0000-000000000000}"/>
           </ac:spMkLst>
         </pc:spChg>
+        <pc:spChg chg="add">
+          <ac:chgData name="David Coronado" userId="58e676e7eb816da9" providerId="LiveId" clId="{7F77D59E-842D-437D-AA28-71301E20DF3F}" dt="2026-05-06T01:17:58.114" v="107"/>
+          <ac:spMkLst>
+            <pc:docMk/>
+            <pc:sldMk cId="0" sldId="264"/>
+            <ac:spMk id="14" creationId="{2E82004B-9EF1-5889-D999-777866251BD1}"/>
+          </ac:spMkLst>
+        </pc:spChg>
+        <pc:picChg chg="add mod">
+          <ac:chgData name="David Coronado" userId="58e676e7eb816da9" providerId="LiveId" clId="{7F77D59E-842D-437D-AA28-71301E20DF3F}" dt="2026-05-06T01:18:06.616" v="111" actId="1076"/>
+          <ac:picMkLst>
+            <pc:docMk/>
+            <pc:sldMk cId="0" sldId="264"/>
+            <ac:picMk id="16" creationId="{17C7EF8D-FCF1-8B98-774E-824FF57B775E}"/>
+          </ac:picMkLst>
+        </pc:picChg>
       </pc:sldChg>
-      <pc:sldChg chg="modSp mod">
-        <pc:chgData name="David Coronado" userId="58e676e7eb816da9" providerId="LiveId" clId="{7F77D59E-842D-437D-AA28-71301E20DF3F}" dt="2026-05-06T00:22:34.852" v="91" actId="20577"/>
+      <pc:sldChg chg="addSp delSp modSp mod">
+        <pc:chgData name="David Coronado" userId="58e676e7eb816da9" providerId="LiveId" clId="{7F77D59E-842D-437D-AA28-71301E20DF3F}" dt="2026-05-06T01:21:49.107" v="125" actId="1076"/>
         <pc:sldMkLst>
           <pc:docMk/>
           <pc:sldMk cId="0" sldId="265"/>
@@ -442,9 +513,25 @@
             <ac:spMk id="13" creationId="{00000000-0000-0000-0000-000000000000}"/>
           </ac:spMkLst>
         </pc:spChg>
+        <pc:picChg chg="add mod">
+          <ac:chgData name="David Coronado" userId="58e676e7eb816da9" providerId="LiveId" clId="{7F77D59E-842D-437D-AA28-71301E20DF3F}" dt="2026-05-06T01:21:49.107" v="125" actId="1076"/>
+          <ac:picMkLst>
+            <pc:docMk/>
+            <pc:sldMk cId="0" sldId="265"/>
+            <ac:picMk id="15" creationId="{610EAF25-A142-1C41-894C-63E9C6510E0C}"/>
+          </ac:picMkLst>
+        </pc:picChg>
+        <pc:picChg chg="add del mod">
+          <ac:chgData name="David Coronado" userId="58e676e7eb816da9" providerId="LiveId" clId="{7F77D59E-842D-437D-AA28-71301E20DF3F}" dt="2026-05-06T01:21:41.903" v="122" actId="478"/>
+          <ac:picMkLst>
+            <pc:docMk/>
+            <pc:sldMk cId="0" sldId="265"/>
+            <ac:picMk id="17" creationId="{E2FF2678-ABBD-3896-882A-9C03B3DC463D}"/>
+          </ac:picMkLst>
+        </pc:picChg>
       </pc:sldChg>
-      <pc:sldChg chg="modSp mod">
-        <pc:chgData name="David Coronado" userId="58e676e7eb816da9" providerId="LiveId" clId="{7F77D59E-842D-437D-AA28-71301E20DF3F}" dt="2026-05-06T00:22:47.761" v="94" actId="20577"/>
+      <pc:sldChg chg="addSp modSp mod">
+        <pc:chgData name="David Coronado" userId="58e676e7eb816da9" providerId="LiveId" clId="{7F77D59E-842D-437D-AA28-71301E20DF3F}" dt="2026-05-06T01:19:27.572" v="117" actId="1076"/>
         <pc:sldMkLst>
           <pc:docMk/>
           <pc:sldMk cId="0" sldId="266"/>
@@ -465,6 +552,22 @@
             <ac:spMk id="13" creationId="{00000000-0000-0000-0000-000000000000}"/>
           </ac:spMkLst>
         </pc:spChg>
+        <pc:picChg chg="add mod">
+          <ac:chgData name="David Coronado" userId="58e676e7eb816da9" providerId="LiveId" clId="{7F77D59E-842D-437D-AA28-71301E20DF3F}" dt="2026-05-06T01:18:56.916" v="113" actId="1076"/>
+          <ac:picMkLst>
+            <pc:docMk/>
+            <pc:sldMk cId="0" sldId="266"/>
+            <ac:picMk id="15" creationId="{875E7B27-7519-D1B0-396C-37D9FABF64C0}"/>
+          </ac:picMkLst>
+        </pc:picChg>
+        <pc:picChg chg="add mod">
+          <ac:chgData name="David Coronado" userId="58e676e7eb816da9" providerId="LiveId" clId="{7F77D59E-842D-437D-AA28-71301E20DF3F}" dt="2026-05-06T01:19:27.572" v="117" actId="1076"/>
+          <ac:picMkLst>
+            <pc:docMk/>
+            <pc:sldMk cId="0" sldId="266"/>
+            <ac:picMk id="17" creationId="{75C0DEB0-E209-9955-9A03-B0D6E6A67E60}"/>
+          </ac:picMkLst>
+        </pc:picChg>
       </pc:sldChg>
       <pc:sldChg chg="modSp mod">
         <pc:chgData name="David Coronado" userId="58e676e7eb816da9" providerId="LiveId" clId="{7F77D59E-842D-437D-AA28-71301E20DF3F}" dt="2026-05-06T00:18:40.907" v="60" actId="20577"/>
@@ -2142,7 +2245,7 @@
                   <a:srgbClr val="94A3B8"/>
                 </a:solidFill>
               </a:rPr>
-              <a:t>Metodologia Pressman (Cap. 17-20)</a:t>
+              <a:t>Metodologia Pressman de los Cap. 17-20</a:t>
             </a:r>
             <a:endParaRPr lang="en-US" sz="1600" dirty="0"/>
           </a:p>
@@ -2156,7 +2259,7 @@
         </p:nvSpPr>
         <p:spPr>
           <a:xfrm>
-            <a:off x="457200" y="4114800"/>
+            <a:off x="457200" y="3650343"/>
             <a:ext cx="11247120" cy="365760"/>
           </a:xfrm>
           <a:prstGeom prst="rect">
@@ -2192,7 +2295,7 @@
         </p:nvSpPr>
         <p:spPr>
           <a:xfrm>
-            <a:off x="457200" y="5303520"/>
+            <a:off x="457200" y="5760720"/>
             <a:ext cx="11247120" cy="274320"/>
           </a:xfrm>
           <a:prstGeom prst="rect">
@@ -2214,9 +2317,67 @@
                   <a:srgbClr val="94A3B8"/>
                 </a:solidFill>
               </a:rPr>
-              <a:t>Mayo 2026</a:t>
+              <a:t>8 de Mayo 2026</a:t>
             </a:r>
             <a:endParaRPr lang="en-US" sz="1200" dirty="0"/>
+          </a:p>
+        </p:txBody>
+      </p:sp>
+      <p:sp>
+        <p:nvSpPr>
+          <p:cNvPr id="7" name="Text 2">
+            <a:extLst>
+              <a:ext uri="{FF2B5EF4-FFF2-40B4-BE49-F238E27FC236}">
+                <a16:creationId xmlns:a16="http://schemas.microsoft.com/office/drawing/2014/main" id="{0483594A-628C-64DB-0561-262D485D1966}"/>
+              </a:ext>
+            </a:extLst>
+          </p:cNvPr>
+          <p:cNvSpPr/>
+          <p:nvPr/>
+        </p:nvSpPr>
+        <p:spPr>
+          <a:xfrm>
+            <a:off x="472440" y="4389121"/>
+            <a:ext cx="11247120" cy="457200"/>
+          </a:xfrm>
+          <a:prstGeom prst="rect">
+            <a:avLst/>
+          </a:prstGeom>
+          <a:noFill/>
+          <a:ln/>
+        </p:spPr>
+        <p:txBody>
+          <a:bodyPr wrap="square" rtlCol="0" anchor="ctr"/>
+          <a:lstStyle/>
+          <a:p>
+            <a:r>
+              <a:rPr lang="es-MX" dirty="0"/>
+              <a:t>Integrantes:</a:t>
+            </a:r>
+          </a:p>
+          <a:p>
+            <a:r>
+              <a:rPr lang="es-MX" dirty="0"/>
+              <a:t>Coronado Hernández David</a:t>
+            </a:r>
+          </a:p>
+          <a:p>
+            <a:r>
+              <a:rPr lang="es-MX" dirty="0"/>
+              <a:t>Gonzales Castillo Gael Essau</a:t>
+            </a:r>
+          </a:p>
+          <a:p>
+            <a:r>
+              <a:rPr lang="es-MX" dirty="0"/>
+              <a:t>Moreno Flores Braulio Edgardo</a:t>
+            </a:r>
+          </a:p>
+          <a:p>
+            <a:r>
+              <a:rPr lang="es-MX" dirty="0"/>
+              <a:t>Reyna Hernández Yaotl Isaias</a:t>
+            </a:r>
           </a:p>
         </p:txBody>
       </p:sp>
@@ -2731,6 +2892,36 @@
           </a:p>
         </p:txBody>
       </p:sp>
+      <p:pic>
+        <p:nvPicPr>
+          <p:cNvPr id="15" name="Imagen 14">
+            <a:extLst>
+              <a:ext uri="{FF2B5EF4-FFF2-40B4-BE49-F238E27FC236}">
+                <a16:creationId xmlns:a16="http://schemas.microsoft.com/office/drawing/2014/main" id="{610EAF25-A142-1C41-894C-63E9C6510E0C}"/>
+              </a:ext>
+            </a:extLst>
+          </p:cNvPr>
+          <p:cNvPicPr>
+            <a:picLocks noChangeAspect="1"/>
+          </p:cNvPicPr>
+          <p:nvPr/>
+        </p:nvPicPr>
+        <p:blipFill>
+          <a:blip r:embed="rId3"/>
+          <a:stretch>
+            <a:fillRect/>
+          </a:stretch>
+        </p:blipFill>
+        <p:spPr>
+          <a:xfrm>
+            <a:off x="7349290" y="1095054"/>
+            <a:ext cx="3013910" cy="5445131"/>
+          </a:xfrm>
+          <a:prstGeom prst="rect">
+            <a:avLst/>
+          </a:prstGeom>
+        </p:spPr>
+      </p:pic>
     </p:spTree>
   </p:cSld>
   <p:clrMapOvr>
@@ -3242,6 +3433,66 @@
           </a:p>
         </p:txBody>
       </p:sp>
+      <p:pic>
+        <p:nvPicPr>
+          <p:cNvPr id="15" name="Imagen 14">
+            <a:extLst>
+              <a:ext uri="{FF2B5EF4-FFF2-40B4-BE49-F238E27FC236}">
+                <a16:creationId xmlns:a16="http://schemas.microsoft.com/office/drawing/2014/main" id="{875E7B27-7519-D1B0-396C-37D9FABF64C0}"/>
+              </a:ext>
+            </a:extLst>
+          </p:cNvPr>
+          <p:cNvPicPr>
+            <a:picLocks noChangeAspect="1"/>
+          </p:cNvPicPr>
+          <p:nvPr/>
+        </p:nvPicPr>
+        <p:blipFill>
+          <a:blip r:embed="rId3"/>
+          <a:stretch>
+            <a:fillRect/>
+          </a:stretch>
+        </p:blipFill>
+        <p:spPr>
+          <a:xfrm>
+            <a:off x="5987025" y="1103812"/>
+            <a:ext cx="2791215" cy="4496427"/>
+          </a:xfrm>
+          <a:prstGeom prst="rect">
+            <a:avLst/>
+          </a:prstGeom>
+        </p:spPr>
+      </p:pic>
+      <p:pic>
+        <p:nvPicPr>
+          <p:cNvPr id="17" name="Imagen 16">
+            <a:extLst>
+              <a:ext uri="{FF2B5EF4-FFF2-40B4-BE49-F238E27FC236}">
+                <a16:creationId xmlns:a16="http://schemas.microsoft.com/office/drawing/2014/main" id="{75C0DEB0-E209-9955-9A03-B0D6E6A67E60}"/>
+              </a:ext>
+            </a:extLst>
+          </p:cNvPr>
+          <p:cNvPicPr>
+            <a:picLocks noChangeAspect="1"/>
+          </p:cNvPicPr>
+          <p:nvPr/>
+        </p:nvPicPr>
+        <p:blipFill>
+          <a:blip r:embed="rId4"/>
+          <a:stretch>
+            <a:fillRect/>
+          </a:stretch>
+        </p:blipFill>
+        <p:spPr>
+          <a:xfrm>
+            <a:off x="8875000" y="1417320"/>
+            <a:ext cx="2829320" cy="4221579"/>
+          </a:xfrm>
+          <a:prstGeom prst="rect">
+            <a:avLst/>
+          </a:prstGeom>
+        </p:spPr>
+      </p:pic>
     </p:spTree>
   </p:cSld>
   <p:clrMapOvr>
@@ -4029,7 +4280,7 @@
         <p:spPr>
           <a:xfrm>
             <a:off x="5897880" y="1180832"/>
-            <a:ext cx="2772954" cy="4762768"/>
+            <a:ext cx="2772954" cy="5314478"/>
           </a:xfrm>
           <a:prstGeom prst="rect">
             <a:avLst/>
@@ -4038,10 +4289,10 @@
       </p:pic>
       <p:pic>
         <p:nvPicPr>
-          <p:cNvPr id="17" name="Imagen 16">
+          <p:cNvPr id="20" name="Imagen 19">
             <a:extLst>
               <a:ext uri="{FF2B5EF4-FFF2-40B4-BE49-F238E27FC236}">
-                <a16:creationId xmlns:a16="http://schemas.microsoft.com/office/drawing/2014/main" id="{08D2BB91-B152-1B59-091D-6F19B99A950C}"/>
+                <a16:creationId xmlns:a16="http://schemas.microsoft.com/office/drawing/2014/main" id="{ECA053AF-0BFB-466A-2456-B51AC1041EFD}"/>
               </a:ext>
             </a:extLst>
           </p:cNvPr>
@@ -4058,8 +4309,8 @@
         </p:blipFill>
         <p:spPr>
           <a:xfrm>
-            <a:off x="8670834" y="1180832"/>
-            <a:ext cx="2885480" cy="4762768"/>
+            <a:off x="8895545" y="1180832"/>
+            <a:ext cx="2454625" cy="5314478"/>
           </a:xfrm>
           <a:prstGeom prst="rect">
             <a:avLst/>
@@ -7899,6 +8150,36 @@
           </a:p>
         </p:txBody>
       </p:sp>
+      <p:pic>
+        <p:nvPicPr>
+          <p:cNvPr id="16" name="Imagen 15">
+            <a:extLst>
+              <a:ext uri="{FF2B5EF4-FFF2-40B4-BE49-F238E27FC236}">
+                <a16:creationId xmlns:a16="http://schemas.microsoft.com/office/drawing/2014/main" id="{17C7EF8D-FCF1-8B98-774E-824FF57B775E}"/>
+              </a:ext>
+            </a:extLst>
+          </p:cNvPr>
+          <p:cNvPicPr>
+            <a:picLocks noChangeAspect="1"/>
+          </p:cNvPicPr>
+          <p:nvPr/>
+        </p:nvPicPr>
+        <p:blipFill>
+          <a:blip r:embed="rId3"/>
+          <a:stretch>
+            <a:fillRect/>
+          </a:stretch>
+        </p:blipFill>
+        <p:spPr>
+          <a:xfrm>
+            <a:off x="7603773" y="1143000"/>
+            <a:ext cx="2576265" cy="5577840"/>
+          </a:xfrm>
+          <a:prstGeom prst="rect">
+            <a:avLst/>
+          </a:prstGeom>
+        </p:spPr>
+      </p:pic>
     </p:spTree>
   </p:cSld>
   <p:clrMapOvr>

</xml_diff>